<commit_message>
s26 PR (c): slide 9 (Direction B and its replacement, the trainability paper) from PROPOSAL_B.md and PROPOSAL_B_REPLACEMENT.md
B1 final from s26/results/b1_feasibility.json (no checkpoint, 8.45 GB to download; openfold
and omegaconf absent, Python 3.13 vs <= 3.9; 8.76 GB resident vs 4.4 GB headroom). B2 and B3
pending; B3's persisted arms recomputed from s13/cache/tors_rows.npz against the production
cache (torsion minus pipeline +0.5557, SE 0.1318, MDE 0.3694, 37W/89L: L14 reproduced). The
replacement paper's claim chain is summarised with the measured/predicted ratio recomputed
from s13/results/geo_pauli.json (median 0.997, 104 cells) and the two claims it will not make.
The lost S7 ESM number (-0.288 A, L11) is kept off the slide and named as document-only in the
notes. Spoken words on slide 9: 248. Verification PASS.

Co-Authored-By: Claude Opus 5 <noreply@anthropic.com>
Claude-Session: https://claude.ai/code/session_01GpmP5oMKmcGvwZvxDqQ53t
</commit_message>
<xml_diff>
--- a/vqe_research_overview.pptx
+++ b/vqe_research_overview.pptx
@@ -2336,13 +2336,164 @@
           </a:p>
           <a:p>
             <a:r>
-              <a:t>PENDING. This slide waits for its build step.</a:t>
+              <a:t>Direction B was: use a large pretrained folding model as the distance prior. Step one asked whether such a model can run here. The answer is no, on three independent grounds. The checkpoints are not on disk and total 8.45 gigabytes. The code needs two packages that are absent, and one of them wants Python 3.9 or lower; this box runs 3.13 on a CPU. And the model needs at least 8.76 gigabytes resident against 4.4 gigabytes of headroom; even at half precision everywhere it is 7.4. Two feasible-scale checks are pending: the contact head alone as a prior input, and an 8-million-parameter language model against the 650-million one. A third asks whether the targets where the pipeline beats a sequence-only predictor form a set I can recognise without the native. The pipeline wins there by 0.56 angstroms, 89 targets to 37. If those checks are null, B is replaced by a paper. The paper says what a force field's Pauli spectrum does and does not predict. Chain geometry fixes which residues a distance can depend on; that is an exact theorem. That fixes the energy's Pauli spectrum, once the raw force field's clash spike is conditioned away. The spectrum times the circuit's own kernel predicts the measured gradient variance with no free parameter: the median ratio is 0.997 over 104 cells. This sprint added the algebra and the product-circuit result. The paper will not claim an advantage, and it will not call a small gradient a plateau.</a:t>
             </a:r>
           </a:p>
           <a:p/>
           <a:p>
             <a:r>
+              <a:t>ALSO (not spoken):</a:t>
+            </a:r>
+          </a:p>
+          <a:p>
+            <a:r>
+              <a:t>B1 verdict: "NO" (`s26/results/b1_feasibility.json`, L13). The one part of a large pretrained model this box already consumes is the ESM-2 650M embedding and its contact head, already 13 of the shipped prior's 183 input columns; its S7 selection value (a document-only -0.288 A whose per-target artefact is lost, L11) is not on this slide and is re-measured by C2's noesm and pca32 rungs. B3 arms, built chains, persisted: pipeline 3.2148, sequence-only torsion predictor 3.7705, constant helix 4.0648; torsion predictor minus pipeline +0.5557 (median +0.2314, SE 0.1318, MDE 0.3694, 37W/89L); the characterisability test (nested ridge against a permutation null) is pending in `s26/results/p_b3.json`. Replacement claims and their artefacts: C1 locality theorem (`s13/results/qarch_locality_geom.json`); C2 raw AMBER's delta-spike spectrum (`s13/results/walsh_xval.json`); C4 spectrum x kernel predicts the gradient variance, median measured/predicted 0.9969 over 104 cells (`s13/results/geo_pauli.json`); C5 the kernel is flat in Pauli weight at depth &gt;= 3 (`s13/results/geo_kernel.json`); C7 the width sweep, slopes -0.649 / -0.252 / -0.047 / -0.311 / -0.243 (`s25/results/q_plateau.json`); C8 the DLA is the full so(2^n) from depth 2 at n = 7, dim 8,128 (`s26/results/q_dla.json`, slide 6); C9 ADAPT-grown circuits at alpha = 1 are product circuits (`s26/results/q_dla.json` adapt sets, `s26/results/q_var.json` slopes; slide 8); C10 the optimiser trains and the readout cannot tell, 0.902 nats, 0.24 x MDE (`s25/results/q_gibbs.json`, `q_alpha.json`); C11 the set-equality theorem, 2,592 cells, 0 violations (`s25/results/q_verify.json`); C12 the deployed Gibbs target is a product state, KL 7.2e-17 ideal, 5.4e-05 on 1A13 (`s26/results/probe/1A13.json`). Venue statement: every number is noiseless exact simulation; a submission would add a noise model, width beyond n = 13, a 2-design control, seeds and error bars on every variance.</a:t>
+            </a:r>
+          </a:p>
+          <a:p/>
+          <a:p>
+            <a:r>
               <a:t>SOURCES (not spoken; token = value &lt;- artefact path [basis]):</a:t>
+            </a:r>
+          </a:p>
+          <a:p>
+            <a:r>
+              <a:t>ARM_MEAN = 3.21477 &lt;- bench_results/baseline_tuning126.json :: science/rmsd_arm/mean [built_chain]</a:t>
+            </a:r>
+          </a:p>
+          <a:p>
+            <a:r>
+              <a:t>B1_DOWNLOAD_GB = 8.45 &lt;- s26/results/b1_feasibility.json :: .../download_bytes_http_head/total_GB</a:t>
+            </a:r>
+          </a:p>
+          <a:p>
+            <a:r>
+              <a:t>B1_FP16_GB = 7.4 &lt;- s26/results/b1_feasibility.json :: .../ram_fp16_GB_parameters_only/total</a:t>
+            </a:r>
+          </a:p>
+          <a:p>
+            <a:r>
+              <a:t>B1_HEADROOM_GB = 4.4 &lt;- s26/LEDGER.md L13 (governor_state 00:19: 64.8% of 16.75 GB used, ceiling 93%) (LEDGER)</a:t>
+            </a:r>
+          </a:p>
+          <a:p>
+            <a:r>
+              <a:t>B1_RESIDENT_GB = 8.76 &lt;- s26/results/b1_feasibility.json :: measured_2026-09-13/c_size_and_ram/ram_as_fair_esm_loads_it_GB/total_resident_minimum</a:t>
+            </a:r>
+          </a:p>
+          <a:p>
+            <a:r>
+              <a:t>B1_VERDICT = NO &lt;- s26/results/b1_feasibility.json :: verdict</a:t>
+            </a:r>
+          </a:p>
+          <a:p>
+            <a:r>
+              <a:t>B3_TORS_L = 89 &lt;- same rows, targets where the pipeline wins (DERIVED)</a:t>
+            </a:r>
+          </a:p>
+          <a:p>
+            <a:r>
+              <a:t>B3_TORS_MINUS_ARM = 0.555693 &lt;- s13/cache/tors_rows.npz['a_pepPos'][*]/rmsd_build minus bench_results/cache/1fc9f2dcf489e2fb/&lt;pdb&gt;.json :: rmsd_arm (paired mean) [built_chain] (DERIVED)</a:t>
+            </a:r>
+          </a:p>
+          <a:p>
+            <a:r>
+              <a:t>B3_TORS_MINUS_ARM_MDE = 0.369361 &lt;- same rows, 2.8016 x SE (DERIVED)</a:t>
+            </a:r>
+          </a:p>
+          <a:p>
+            <a:r>
+              <a:t>B3_TORS_MINUS_ARM_MEDIAN = 0.231395 &lt;- same rows, paired median [built_chain] (DERIVED)</a:t>
+            </a:r>
+          </a:p>
+          <a:p>
+            <a:r>
+              <a:t>B3_TORS_MINUS_ARM_SE = 0.131839 &lt;- same rows, SE of the paired mean (DERIVED)</a:t>
+            </a:r>
+          </a:p>
+          <a:p>
+            <a:r>
+              <a:t>B3_TORS_W = 37 &lt;- same rows, targets where the torsion predictor beats the pipeline (DERIVED)</a:t>
+            </a:r>
+          </a:p>
+          <a:p>
+            <a:r>
+              <a:t>DLA_SO128 = 8128 &lt;- s26/results/q_dla.json :: results/fixed/n7_L3/dim_so</a:t>
+            </a:r>
+          </a:p>
+          <a:p>
+            <a:r>
+              <a:t>HELIX = 4.06475 &lt;- s12/results/s14_ladder.json :: rows/L0_constant_helix/mean [built_chain]</a:t>
+            </a:r>
+          </a:p>
+          <a:p>
+            <a:r>
+              <a:t>PAULI_N_CELLS = 104 &lt;- s13/results/geo_pauli.json :: len(cells)</a:t>
+            </a:r>
+          </a:p>
+          <a:p>
+            <a:r>
+              <a:t>PAULI_RATIO_LEGACY = 0.996949 &lt;- s13/results/geo_pauli.json :: cells[*]/legacy/ratio_meas_over_pred_exact (median) (DERIVED)</a:t>
+            </a:r>
+          </a:p>
+          <a:p>
+            <a:r>
+              <a:t>PROD_KL_1A13 = 5.43789e-05 &lt;- s26/results/probe/1A13.json :: product_diagnostics/zrank/kl_gibbs_to_product</a:t>
+            </a:r>
+          </a:p>
+          <a:p>
+            <a:r>
+              <a:t>PROD_KL_IDEAL = 7.23403e-17 &lt;- s26/results/probe/1A13.json :: product_diagnostics/ideal_ladder/kl_gibbs_to_product</a:t>
+            </a:r>
+          </a:p>
+          <a:p>
+            <a:r>
+              <a:t>Q_CELLS = 2592 &lt;- s25/results/q_verify.json :: results/n_cells</a:t>
+            </a:r>
+          </a:p>
+          <a:p>
+            <a:r>
+              <a:t>Q_CIRC_VS_GIBBS_X = 0.239914 &lt;- s25/results/q_alpha.json :: .../'circuit - exact Boltzmann @T=0.3'/eff_over_mde</a:t>
+            </a:r>
+          </a:p>
+          <a:p>
+            <a:r>
+              <a:t>Q_KL_NATS = 0.901916 &lt;- s25/results/q_gibbs.json :: results/divergence_ladder/[T=0.3]/ladder/'50 Adam steps (DEPLOYED)'/kl_nats</a:t>
+            </a:r>
+          </a:p>
+          <a:p>
+            <a:r>
+              <a:t>Q_VIOLATIONS = 0 &lt;- s25/results/q_verify.json :: results/'SUBSET-hood violations  &lt;- THE THEOREM'</a:t>
+            </a:r>
+          </a:p>
+          <a:p>
+            <a:r>
+              <a:t>SLOPE_A01_T0 = -0.0471589 &lt;- s25/results/q_plateau.json :: results/cvar_alpha01_T0/log2_slope_per_qubit</a:t>
+            </a:r>
+          </a:p>
+          <a:p>
+            <a:r>
+              <a:t>SLOPE_A025_T0 = -0.252201 &lt;- s25/results/q_plateau.json :: results/cvar_alpha025_T0/log2_slope_per_qubit</a:t>
+            </a:r>
+          </a:p>
+          <a:p>
+            <a:r>
+              <a:t>SLOPE_A025_T03 = -0.242884 &lt;- s25/results/q_plateau.json :: results/deployed_a025_T03/log2_slope_per_qubit</a:t>
+            </a:r>
+          </a:p>
+          <a:p>
+            <a:r>
+              <a:t>SLOPE_A1_T03 = -0.310535 &lt;- s25/results/q_plateau.json :: results/deployed_a1_T03/log2_slope_per_qubit</a:t>
+            </a:r>
+          </a:p>
+          <a:p>
+            <a:r>
+              <a:t>SLOPE_LIN = -0.649187 &lt;- s25/results/q_plateau.json :: results/linear_alpha1_T0/log2_slope_per_qubit</a:t>
+            </a:r>
+          </a:p>
+          <a:p>
+            <a:r>
+              <a:t>TORS = 3.77046 &lt;- s13/results/tors_eval.json :: reports/a_pepPos/build/mean [built_chain]</a:t>
             </a:r>
           </a:p>
         </p:txBody>
@@ -9683,7 +9834,7 @@
                 </a:solidFill>
                 <a:latin typeface="Calibri"/>
               </a:rPr>
-              <a:t>Direction B: a learned folding model as the prior</a:t>
+              <a:t>Direction B: a learned folding model as the prior, and its replacement</a:t>
             </a:r>
           </a:p>
         </p:txBody>
@@ -9752,7 +9903,7 @@
                 </a:solidFill>
                 <a:latin typeface="Calibri"/>
               </a:rPr>
-              <a:t>9 / 11    PENDING: s26/PROPOSAL_B.md and s26/PROPOSAL_B_REPLACEMENT.md</a:t>
+              <a:t>9 / 11    from s26/PROPOSAL_B.md (lane P, DRAFT; B1 final) and s26/PROPOSAL_B_REPLACEMENT.md (lane Q); the A2 and A4 figures are on slides 6 and 8</a:t>
             </a:r>
           </a:p>
         </p:txBody>
@@ -9765,8 +9916,8 @@
         </p:nvSpPr>
         <p:spPr>
           <a:xfrm>
-            <a:off x="731520" y="2011680"/>
-            <a:ext cx="10698480" cy="2743200"/>
+            <a:off x="548640" y="1280160"/>
+            <a:ext cx="5577840" cy="5120640"/>
           </a:xfrm>
           <a:prstGeom prst="rect">
             <a:avLst/>
@@ -9781,33 +9932,376 @@
           <a:p>
             <a:pPr>
               <a:spcAft>
-                <a:spcPts val="400"/>
-              </a:spcAft>
-            </a:pPr>
-            <a:r>
-              <a:rPr sz="2000" b="0">
+                <a:spcPts val="300"/>
+              </a:spcAft>
+            </a:pPr>
+            <a:r>
+              <a:rPr sz="1150" b="1">
                 <a:solidFill>
                   <a:srgbClr val="F2A93B"/>
                 </a:solidFill>
                 <a:latin typeface="Calibri"/>
               </a:rPr>
-              <a:t>PENDING. This slide is filled from s26/PROPOSAL_B.md and s26/PROPOSAL_B_REPLACEMENT.md when it lands.</a:t>
-            </a:r>
-          </a:p>
-          <a:p>
-            <a:pPr>
-              <a:spcAft>
-                <a:spcPts val="400"/>
-              </a:spcAft>
-            </a:pPr>
-            <a:r>
-              <a:rPr sz="1600" b="0">
+              <a:t>What the proposal says</a:t>
+            </a:r>
+          </a:p>
+          <a:p>
+            <a:pPr>
+              <a:spcAft>
+                <a:spcPts val="300"/>
+              </a:spcAft>
+            </a:pPr>
+            <a:r>
+              <a:rPr sz="1150" b="0">
                 <a:solidFill>
                   <a:srgbClr val="ECECF0"/>
                 </a:solidFill>
                 <a:latin typeface="Calibri"/>
               </a:rPr>
-              <a:t>Until then nothing on it is claimed.</a:t>
+              <a:t>• Replace or augment the shipped distance prior with the output of a large pretrained folding model, because the prior's accuracy is the only steep lever the record measured.</a:t>
+            </a:r>
+          </a:p>
+          <a:p>
+            <a:pPr>
+              <a:spcAft>
+                <a:spcPts val="300"/>
+              </a:spcAft>
+            </a:pPr>
+            <a:r>
+              <a:rPr sz="1150" b="1">
+                <a:solidFill>
+                  <a:srgbClr val="F2A93B"/>
+                </a:solidFill>
+                <a:latin typeface="Calibri"/>
+              </a:rPr>
+              <a:t>B1, final: the folding model cannot run on this machine</a:t>
+            </a:r>
+          </a:p>
+          <a:p>
+            <a:pPr>
+              <a:spcAft>
+                <a:spcPts val="300"/>
+              </a:spcAft>
+            </a:pPr>
+            <a:r>
+              <a:rPr sz="1150" b="0">
+                <a:solidFill>
+                  <a:srgbClr val="ECECF0"/>
+                </a:solidFill>
+                <a:latin typeface="Calibri"/>
+              </a:rPr>
+              <a:t>• no checkpoint on disk; 8.45 GB to download</a:t>
+            </a:r>
+          </a:p>
+          <a:p>
+            <a:pPr>
+              <a:spcAft>
+                <a:spcPts val="300"/>
+              </a:spcAft>
+            </a:pPr>
+            <a:r>
+              <a:rPr sz="1150" b="0">
+                <a:solidFill>
+                  <a:srgbClr val="ECECF0"/>
+                </a:solidFill>
+                <a:latin typeface="Calibri"/>
+              </a:rPr>
+              <a:t>• openfold and omegaconf absent; openfold needs nvcc and Python &lt;= 3.9; this box is Python 3.13, CPU-only torch</a:t>
+            </a:r>
+          </a:p>
+          <a:p>
+            <a:pPr>
+              <a:spcAft>
+                <a:spcPts val="300"/>
+              </a:spcAft>
+            </a:pPr>
+            <a:r>
+              <a:rPr sz="1150" b="0">
+                <a:solidFill>
+                  <a:srgbClr val="ECECF0"/>
+                </a:solidFill>
+                <a:latin typeface="Calibri"/>
+              </a:rPr>
+              <a:t>• 8.76 GB resident as fair-esm loads it (fp16 LM, fp32 trunk) against 4.4 GB of headroom; fp16 everywhere is still 7.4 GB</a:t>
+            </a:r>
+          </a:p>
+          <a:p>
+            <a:pPr>
+              <a:spcAft>
+                <a:spcPts val="300"/>
+              </a:spcAft>
+            </a:pPr>
+            <a:r>
+              <a:rPr sz="1150" b="1">
+                <a:solidFill>
+                  <a:srgbClr val="F2A93B"/>
+                </a:solidFill>
+                <a:latin typeface="Calibri"/>
+              </a:rPr>
+              <a:t>B2, pending: the feasible-scale ladder</a:t>
+            </a:r>
+          </a:p>
+          <a:p>
+            <a:pPr>
+              <a:spcAft>
+                <a:spcPts val="300"/>
+              </a:spcAft>
+            </a:pPr>
+            <a:r>
+              <a:rPr sz="1150" b="0">
+                <a:solidFill>
+                  <a:srgbClr val="ECECF0"/>
+                </a:solidFill>
+                <a:latin typeface="Calibri"/>
+              </a:rPr>
+              <a:t>• the ESM-2 contact head alone as a prior input; the 8M language model against the 650M (rungs conly and esm8m of the C2 ladder)</a:t>
+            </a:r>
+          </a:p>
+          <a:p>
+            <a:pPr>
+              <a:spcAft>
+                <a:spcPts val="300"/>
+              </a:spcAft>
+            </a:pPr>
+            <a:r>
+              <a:rPr sz="1150" b="1">
+                <a:solidFill>
+                  <a:srgbClr val="F2A93B"/>
+                </a:solidFill>
+                <a:latin typeface="Calibri"/>
+              </a:rPr>
+              <a:t>B3, pending: where the pipeline beats sequence-only, and is that set recognisable native-free?</a:t>
+            </a:r>
+          </a:p>
+          <a:p>
+            <a:pPr>
+              <a:spcAft>
+                <a:spcPts val="300"/>
+              </a:spcAft>
+            </a:pPr>
+            <a:r>
+              <a:rPr sz="1150" b="0">
+                <a:solidFill>
+                  <a:srgbClr val="ECECF0"/>
+                </a:solidFill>
+                <a:latin typeface="Calibri"/>
+              </a:rPr>
+              <a:t>• built chains: pipeline 3.2148, sequence-only torsion predictor 3.7705, constant helix 4.0648 A; torsion minus pipeline +0.5557 (SE 0.1318, MDE 0.3694, 37W/89L); the classifier test is pending</a:t>
+            </a:r>
+          </a:p>
+          <a:p>
+            <a:pPr>
+              <a:spcAft>
+                <a:spcPts val="300"/>
+              </a:spcAft>
+            </a:pPr>
+            <a:r>
+              <a:rPr sz="1150" b="1">
+                <a:solidFill>
+                  <a:srgbClr val="ECECF0"/>
+                </a:solidFill>
+                <a:latin typeface="Calibri"/>
+              </a:rPr>
+              <a:t>• Verdict: PENDING B2/B3. If null: REPLACE with the trainability paper (right).</a:t>
+            </a:r>
+          </a:p>
+        </p:txBody>
+      </p:sp>
+      <p:sp>
+        <p:nvSpPr>
+          <p:cNvPr id="6" name="TextBox 5"/>
+          <p:cNvSpPr txBox="1"/>
+          <p:nvPr/>
+        </p:nvSpPr>
+        <p:spPr>
+          <a:xfrm>
+            <a:off x="6355080" y="1280160"/>
+            <a:ext cx="5440680" cy="5120640"/>
+          </a:xfrm>
+          <a:prstGeom prst="rect">
+            <a:avLst/>
+          </a:prstGeom>
+          <a:noFill/>
+        </p:spPr>
+        <p:txBody>
+          <a:bodyPr wrap="square">
+            <a:spAutoFit/>
+          </a:bodyPr>
+          <a:lstStyle/>
+          <a:p>
+            <a:pPr>
+              <a:spcAft>
+                <a:spcPts val="300"/>
+              </a:spcAft>
+            </a:pPr>
+            <a:r>
+              <a:rPr sz="1150" b="1">
+                <a:solidFill>
+                  <a:srgbClr val="F2A93B"/>
+                </a:solidFill>
+                <a:latin typeface="Calibri"/>
+              </a:rPr>
+              <a:t>The replacement: publish the trainability result</a:t>
+            </a:r>
+          </a:p>
+          <a:p>
+            <a:pPr>
+              <a:spcAft>
+                <a:spcPts val="300"/>
+              </a:spcAft>
+            </a:pPr>
+            <a:r>
+              <a:rPr sz="1150" b="0">
+                <a:solidFill>
+                  <a:srgbClr val="ECECF0"/>
+                </a:solidFill>
+                <a:latin typeface="Calibri"/>
+              </a:rPr>
+              <a:t>• chain geometry fixes which residues a distance term can depend on (exact theorem); that fixes the energy's Pauli spectrum once raw AMBER's clash spike is conditioned away</a:t>
+            </a:r>
+          </a:p>
+          <a:p>
+            <a:pPr>
+              <a:spcAft>
+                <a:spcPts val="300"/>
+              </a:spcAft>
+            </a:pPr>
+            <a:r>
+              <a:rPr sz="1150" b="0">
+                <a:solidFill>
+                  <a:srgbClr val="ECECF0"/>
+                </a:solidFill>
+                <a:latin typeface="Calibri"/>
+              </a:rPr>
+              <a:t>• the spectrum times the circuit's own kernel predicts the measured gradient variance with no free parameter: median measured/predicted 0.997 over 104 cells</a:t>
+            </a:r>
+          </a:p>
+          <a:p>
+            <a:pPr>
+              <a:spcAft>
+                <a:spcPts val="300"/>
+              </a:spcAft>
+            </a:pPr>
+            <a:r>
+              <a:rPr sz="1150" b="0">
+                <a:solidFill>
+                  <a:srgbClr val="ECECF0"/>
+                </a:solidFill>
+                <a:latin typeface="Calibri"/>
+              </a:rPr>
+              <a:t>• at depth &gt;= 3 the kernel is flat in Pauli weight: the force field's locality is not what limits training; the width is</a:t>
+            </a:r>
+          </a:p>
+          <a:p>
+            <a:pPr>
+              <a:spcAft>
+                <a:spcPts val="300"/>
+              </a:spcAft>
+            </a:pPr>
+            <a:r>
+              <a:rPr sz="1150" b="0">
+                <a:solidFill>
+                  <a:srgbClr val="ECECF0"/>
+                </a:solidFill>
+                <a:latin typeface="Calibri"/>
+              </a:rPr>
+              <a:t>• the Lie algebra is the full so(2^n) from depth 2 (dim 8,128 at n = 7): nothing algebraic protects the ansatz at scale; n = 4..13 at depth 3 is the shallow regime</a:t>
+            </a:r>
+          </a:p>
+          <a:p>
+            <a:pPr>
+              <a:spcAft>
+                <a:spcPts val="300"/>
+              </a:spcAft>
+            </a:pPr>
+            <a:r>
+              <a:rPr sz="1150" b="0">
+                <a:solidFill>
+                  <a:srgbClr val="ECECF0"/>
+                </a:solidFill>
+                <a:latin typeface="Calibri"/>
+              </a:rPr>
+              <a:t>• the deployed Gibbs target is a product state (KL to its product of marginals 5.4e-05 on 1A13); an ADAPT-grown circuit on it grows no entanglement, so its gradients do not decay because there is nothing to train</a:t>
+            </a:r>
+          </a:p>
+          <a:p>
+            <a:pPr>
+              <a:spcAft>
+                <a:spcPts val="300"/>
+              </a:spcAft>
+            </a:pPr>
+            <a:r>
+              <a:rPr sz="1150" b="0">
+                <a:solidFill>
+                  <a:srgbClr val="ECECF0"/>
+                </a:solidFill>
+                <a:latin typeface="Calibri"/>
+              </a:rPr>
+              <a:t>• the optimiser trains (78% to 89% of the gap) and the readout cannot tell (0.24 x MDE); the tail is a subset of the classical prefix (2,592 cells, 0 violations)</a:t>
+            </a:r>
+          </a:p>
+          <a:p>
+            <a:pPr>
+              <a:spcAft>
+                <a:spcPts val="300"/>
+              </a:spcAft>
+            </a:pPr>
+            <a:r>
+              <a:rPr sz="1150" b="1">
+                <a:solidFill>
+                  <a:srgbClr val="F2A93B"/>
+                </a:solidFill>
+                <a:latin typeface="Calibri"/>
+              </a:rPr>
+              <a:t>Two claims the paper will not make</a:t>
+            </a:r>
+          </a:p>
+          <a:p>
+            <a:pPr>
+              <a:spcAft>
+                <a:spcPts val="300"/>
+              </a:spcAft>
+            </a:pPr>
+            <a:r>
+              <a:rPr sz="1150" b="0">
+                <a:solidFill>
+                  <a:srgbClr val="ECECF0"/>
+                </a:solidFill>
+                <a:latin typeface="Calibri"/>
+              </a:rPr>
+              <a:t>• a quantum advantage (7 qubits, exact simulation, selection classical by theorem, a product-state target)</a:t>
+            </a:r>
+          </a:p>
+          <a:p>
+            <a:pPr>
+              <a:spcAft>
+                <a:spcPts val="300"/>
+              </a:spcAft>
+            </a:pPr>
+            <a:r>
+              <a:rPr sz="1150" b="0">
+                <a:solidFill>
+                  <a:srgbClr val="ECECF0"/>
+                </a:solidFill>
+                <a:latin typeface="Calibri"/>
+              </a:rPr>
+              <a:t>• a barren plateau from a small gradient; 'no plateau' is said only as 'at n &lt;= 13, depth 3, this ansatz'</a:t>
+            </a:r>
+          </a:p>
+          <a:p>
+            <a:pPr>
+              <a:spcAft>
+                <a:spcPts val="300"/>
+              </a:spcAft>
+            </a:pPr>
+            <a:r>
+              <a:rPr sz="1150" b="0">
+                <a:solidFill>
+                  <a:srgbClr val="A8A8B6"/>
+                </a:solidFill>
+                <a:latin typeface="Calibri"/>
+              </a:rPr>
+              <a:t>• Venue: noiseless exact simulation throughout; a submission adds a noise model, width beyond 13, a 2-design control, error bars</a:t>
             </a:r>
           </a:p>
         </p:txBody>

</xml_diff>

<commit_message>
s26 PR: C5 closure (L132, PROPOSAL_C.md addendum 2) and the raw rung's status (L133) applied to slide 10; the deck is final; ledger L134
Slide 10 and its notes state C5 as CLOSED with every number read from s26/results/p_c5.json
(complete: true): GLOBAL null (-0.009 / +0.031 A), RIDGE harmful (+0.164 A, 1.79x MDE, 5/5
folds, indistinguishable from a random correction of the same size), ORACLE ceilings -1.87 /
-3.13 A; the raw rung is NOT RUN (4 of 5 folds trained). Verification PASS: 11 slides, 0 dashes,
0 banned words, 249 / 248 / 249 spoken words on slides 8 / 9 / 10. Registry 520 tokens.

Co-Authored-By: Claude Opus 5 <noreply@anthropic.com>
Claude-Session: https://claude.ai/code/session_01GpmP5oMKmcGvwZvxDqQ53t
</commit_message>
<xml_diff>
--- a/vqe_research_overview.pptx
+++ b/vqe_research_overview.pptx
@@ -645,7 +645,7 @@
           </a:p>
           <a:p>
             <a:r>
-              <a:t>Verdict KEEP WITH EDITS, final (`s26/PROPOSAL_C.md`, commit 0a85323f with addendum 1; coordinator L117; Adversary L120 STANDS). The four edits: (1) C2 "learn a better prior from better inputs" becomes "the prior's inputs are measured out at n = 126": the ESM-2 650M channel is the whole of the channel this instrument can see (+0.208 A built chain, +0.330 A selection, 5/5 folds), and no reduction, expansion, capacity, joint-consistency or pool-histogram variant of it moves the endpoint beyond 0.12 A against MDEs of 0.13 to 0.20 A; the lever that stays open is a larger language model, which does not fit this box (B1). (2) C3 "refine with physics" becomes "keep AMBER as a validity step only". (3) C4 "route the set size and scale" becomes "closed": 12 m* routers on four feature blocks no previous router used, 11 pointing the harmful way, the largest +0.068 A at 0.91 x MDE, none clearing its MDE; 6 s* routers, all with the wrong sign (rho -0.21 to -0.10), costing +0.007 to +0.027 A against s = 1 (`s26/results/p_c4.json`, L110, L115); C5 (predict and subtract the common mode) was RUNNING at the proposal's 02:12 stamp (`s26/PROPOSAL_C.md` addendum 1, correcting a pre-written outcome per L120); at this build `s26/results/p_c5.json` holds 126 checkpointed rows with complete = False, so it is NOT A RESULT; lane P appends a final addendum when the run finishes or at 04:15, and the record's prior for it is a null (S16, S19 L14, S24 L7). The raw rung has 3 of 5 fold models trained and was not evaluated. (4) "The prior's derivative is steep and the prior's inputs are flat": every achievable rung moves at cosine 0.2 to 0.5 to the native's direction (S25 L12). C1 (L26): closures reproduced, 3.0433 to 3.0258 real vs 2.5342 to 2.1460 leaked; 2.6087 vs 3.4676. C2, all nine evaluated rungs, built chain (rebuild basis 3.2126), effect (x MDE, fold CI, folds): noesm +0.208 (1.01 x, [+0.0986, +0.3942], 5/5, WORSE, Type-M); conly +0.122 (0.62 x, [-0.0350, +0.2674]); esm8m +0.242 (1.17 x, [+0.1134, +0.3853], 5/5, WORSE, Type-M); pca32 identity (126 ties); pca32f +0.018 (0.13 x, [-0.0725, +0.0970]); pca128 +0.076 (0.43 x, [-0.0691, +0.2157]); wide +0.032 (0.25 x, [-0.0300, +0.1279]); pairnet +0.041 (0.30 x, [-0.0442, +0.1143]); mix identity (126 ties, lam* = 0 on 5/5 folds); raw: 3 of 5 folds trained, not evaluated. No rung is better than the shipped prior on the built chain (False). C3 (L39, L46, L87, L100; `s26/C3_RESULT.md` addenda 1 to 4): AMBER vs the built chain +0.0207 (fold CI [+0.0154, +0.0290], 2.16 x); vs a random move of its own size +0.0111 ([+0.0062, +0.0171], 1.12 x, Type-M: sign measured, size an upper bound; replication +0.0100); vs a same-size move toward a random pool member +0.0385 ([+0.0298, +0.0479]; replication +0.0414); the toward-member control itself improves the chain, -0.0178, replicated at -0.0207 [-0.0250, -0.0166], a statement about the projection's cost (S16 L27), not about physics; ORACLE cosine -0.049. The validity axis (`s26/results/ph_validity.json`, L100): heavy-atom pairs below 2.0 A 0.444 to 0.008 per target (34 targets to 1); closest pair 2.36 to 2.78 A; bond strain 1.3%, angle strain 2.5%, omega non-planarity 6.6 deg; Ramachandran favoured 0.930 to 0.911; 125 of 126 converge below 1000 kcal/mol (9KAR ends at 1262); a validity step on 124 of 126, on 2BP4 and 9KAR it breaks a virtual bond. Stage 2 reduces to stage 1 because the best C2 rung is the shipped prior (L112, addendum 4). The calibration flag, restated per L123: the pool's own disagreement predicts the emitted chain's error (Spearman +0.452 partial on n and Rg, fold CI [+0.2799, +0.6093]); the relaxation's displacement tracks that disagreement at rho 0.76 and adds nothing given it (`s26/results/a_strain_vs_spread.json`); never a selector.</a:t>
+              <a:t>Verdict KEEP WITH EDITS, final (`s26/PROPOSAL_C.md` with addenda 1 and 2, 03:54; coordinator L117; Adversary L120 STANDS). The four edits: (1) C2 "learn a better prior from better inputs" becomes "the prior's inputs are measured out at n = 126": the ESM-2 650M channel is the whole of the channel this instrument can see (+0.208 A built chain, +0.330 A selection, 5/5 folds), and no reduction, expansion, capacity, joint-consistency or pool-histogram variant of it moves the endpoint beyond 0.12 A against MDEs of 0.13 to 0.20 A; the lever that stays open is a larger language model, which does not fit this box (B1). (2) C3 "refine with physics" becomes "keep AMBER as a validity step only". (3) C4 "route the set size and scale" becomes "closed": 12 m* routers on four feature blocks no previous router used, 11 pointing the harmful way, the largest +0.068 A at 0.91 x MDE, none clearing its MDE; 6 s* routers, all with the wrong sign (rho -0.21 to -0.10), costing +0.007 to +0.027 A against s = 1 (`s26/results/p_c4.json`, L110, L115); C5 (predict and subtract the common mode) is CLOSED (`s26/PROPOSAL_C.md` addendum 2, 03:54; ledger L132; `s26/results/p_c5.json` complete = True, 126/126): subtracting a predicted common-mode correction on held-out folds is null to harmful on the built chain (rebuild basis): GLOBAL in the coordinate frame -0.0090 A (-0.23 x MDE, fold CI [-0.0331, +0.0185], NOT MEASURED), GLOBAL in distance space +0.0312 (0.60 x, NOT MEASURED), RIDGE in distance space on 45 native-free features +0.1643 (1.79 x, fold CI [+0.1176, +0.2253], 5/5 folds, WORSE), indistinguishable from a random correction of the same size (+0.1351, 1.33 x); the ORACLE ceilings are -1.875 A (distance space) and -3.129 A (coordinate frame): the common mode is most of the error and nothing native-free touches it (S16, S19 L14, S24 L7 confirmed on the same operator). The raw rung (1280-d input) is NOT RUN: 4 of 5 fold models trained, no evaluation (L133); its inputs are bracketed by the null pca32f and pca128 rungs. (4) "The prior's derivative is steep and the prior's inputs are flat": every achievable rung moves at cosine 0.2 to 0.5 to the native's direction (S25 L12). C1 (L26): closures reproduced, 3.0433 to 3.0258 real vs 2.5342 to 2.1460 leaked; 2.6087 vs 3.4676. C2, all nine evaluated rungs, built chain (rebuild basis 3.2126), effect (x MDE, fold CI, folds): noesm +0.208 (1.01 x, [+0.0986, +0.3942], 5/5, WORSE, Type-M); conly +0.122 (0.62 x, [-0.0350, +0.2674]); esm8m +0.242 (1.17 x, [+0.1134, +0.3853], 5/5, WORSE, Type-M); pca32 identity (126 ties); pca32f +0.018 (0.13 x, [-0.0725, +0.0970]); pca128 +0.076 (0.43 x, [-0.0691, +0.2157]); wide +0.032 (0.25 x, [-0.0300, +0.1279]); pairnet +0.041 (0.30 x, [-0.0442, +0.1143]); mix identity (126 ties, lam* = 0 on 5/5 folds); raw: NOT RUN, 4 of 5 folds trained, not evaluated (L133). No rung is better than the shipped prior on the built chain (False). C3 (L39, L46, L87, L100; `s26/C3_RESULT.md` addenda 1 to 4): AMBER vs the built chain +0.0207 (fold CI [+0.0154, +0.0290], 2.16 x); vs a random move of its own size +0.0111 ([+0.0062, +0.0171], 1.12 x, Type-M: sign measured, size an upper bound; replication +0.0100); vs a same-size move toward a random pool member +0.0385 ([+0.0298, +0.0479]; replication +0.0414); the toward-member control itself improves the chain, -0.0178, replicated at -0.0207 [-0.0250, -0.0166], a statement about the projection's cost (S16 L27), not about physics; ORACLE cosine -0.049. The validity axis (`s26/results/ph_validity.json`, L100): heavy-atom pairs below 2.0 A 0.444 to 0.008 per target (34 targets to 1); closest pair 2.36 to 2.78 A; bond strain 1.3%, angle strain 2.5%, omega non-planarity 6.6 deg; Ramachandran favoured 0.930 to 0.911; 125 of 126 converge below 1000 kcal/mol (9KAR ends at 1262); a validity step on 124 of 126, on 2BP4 and 9KAR it breaks a virtual bond. Stage 2 reduces to stage 1 because the best C2 rung is the shipped prior (L112, addendum 4). The calibration flag, restated per L123: the pool's own disagreement predicts the emitted chain's error (Spearman +0.452 partial on n and Rg, fold CI [+0.2799, +0.6093]); the relaxation's displacement tracks that disagreement at rho 0.76 and adds nothing given it (`s26/results/a_strain_vs_spread.json`); never a selector.</a:t>
             </a:r>
           </a:p>
           <a:p/>
@@ -966,12 +966,87 @@
           </a:p>
           <a:p>
             <a:r>
-              <a:t>C5_COMPLETE = False &lt;- s26/results/p_c5.json :: complete (absent or false = not a result) (DERIVED)</a:t>
-            </a:r>
-          </a:p>
-          <a:p>
-            <a:r>
-              <a:t>C5_N_ROWS = 126 &lt;- s26/results/p_c5.json :: rows (count of checkpointed targets at build time) (DERIVED)</a:t>
+              <a:t>C5_COMPLETE = True &lt;- s26/results/p_c5.json :: complete (absent or false = not a result) (DERIVED)</a:t>
+            </a:r>
+          </a:p>
+          <a:p>
+            <a:r>
+              <a:t>C5_GLOBAL_R1 = 0.031217 &lt;- s26/results/p_c5.json :: summary/global_R1_a0.5/effect [built_chain (rebuild basis 3.2126)]</a:t>
+            </a:r>
+          </a:p>
+          <a:p>
+            <a:r>
+              <a:t>C5_GLOBAL_R1_VERDICT = NOT MEASURED &lt;- s26/results/p_c5.json :: summary/global_R1_a0.5/verdict</a:t>
+            </a:r>
+          </a:p>
+          <a:p>
+            <a:r>
+              <a:t>C5_GLOBAL_R1_X = 0.601462 &lt;- s26/results/p_c5.json :: summary/global_R1_a0.5/effect_over_mde</a:t>
+            </a:r>
+          </a:p>
+          <a:p>
+            <a:r>
+              <a:t>C5_GLOBAL_R2 = -0.00903203 &lt;- s26/results/p_c5.json :: summary/global_R2_a0.5/effect [built_chain (rebuild basis 3.2126)]</a:t>
+            </a:r>
+          </a:p>
+          <a:p>
+            <a:r>
+              <a:t>C5_GLOBAL_R2_CI = [-0.03312525896366089, 0.018532209148554846] &lt;- s26/results/p_c5.json :: summary/global_R2_a0.5/ci95_fold</a:t>
+            </a:r>
+          </a:p>
+          <a:p>
+            <a:r>
+              <a:t>C5_GLOBAL_R2_VERDICT = NOT MEASURED &lt;- s26/results/p_c5.json :: summary/global_R2_a0.5/verdict</a:t>
+            </a:r>
+          </a:p>
+          <a:p>
+            <a:r>
+              <a:t>C5_GLOBAL_R2_X = -0.230242 &lt;- s26/results/p_c5.json :: summary/global_R2_a0.5/effect_over_mde</a:t>
+            </a:r>
+          </a:p>
+          <a:p>
+            <a:r>
+              <a:t>C5_ORACLE_R1 = -1.87494 &lt;- s26/results/p_c5.json :: summary/oracle_R1/effect [built_chain (rebuild basis 3.2126)]</a:t>
+            </a:r>
+          </a:p>
+          <a:p>
+            <a:r>
+              <a:t>C5_ORACLE_R2 = -3.12927 &lt;- s26/results/p_c5.json :: summary/oracle_R2/effect [built_chain (rebuild basis 3.2126)]</a:t>
+            </a:r>
+          </a:p>
+          <a:p>
+            <a:r>
+              <a:t>C5_RANDOM_R1 = 0.135095 &lt;- s26/results/p_c5.json :: summary/random_R1/effect [built_chain (rebuild basis 3.2126)]</a:t>
+            </a:r>
+          </a:p>
+          <a:p>
+            <a:r>
+              <a:t>C5_RANDOM_R1_X = 1.32747 &lt;- s26/results/p_c5.json :: summary/random_R1/effect_over_mde</a:t>
+            </a:r>
+          </a:p>
+          <a:p>
+            <a:r>
+              <a:t>C5_RIDGE_R1 = 0.164312 &lt;- s26/results/p_c5.json :: summary/ridge_R1/effect [built_chain (rebuild basis 3.2126)]</a:t>
+            </a:r>
+          </a:p>
+          <a:p>
+            <a:r>
+              <a:t>C5_RIDGE_R1_CI = [0.1175672352707539, 0.22529816879162798] &lt;- s26/results/p_c5.json :: summary/ridge_R1/ci95_fold</a:t>
+            </a:r>
+          </a:p>
+          <a:p>
+            <a:r>
+              <a:t>C5_RIDGE_R1_FOLDS = 5 &lt;- s26/results/p_c5.json :: summary/ridge_R1/folds_same_sign</a:t>
+            </a:r>
+          </a:p>
+          <a:p>
+            <a:r>
+              <a:t>C5_RIDGE_R1_VERDICT = WORSE &lt;- s26/results/p_c5.json :: summary/ridge_R1/verdict</a:t>
+            </a:r>
+          </a:p>
+          <a:p>
+            <a:r>
+              <a:t>C5_RIDGE_R1_X = 1.78626 &lt;- s26/results/p_c5.json :: summary/ridge_R1/effect_over_mde</a:t>
             </a:r>
           </a:p>
           <a:p>
@@ -981,7 +1056,7 @@
           </a:p>
           <a:p>
             <a:r>
-              <a:t>RAW_FOLDS_TRAINED = 3 &lt;- s26/models/p_ladder/raw_fold*_s0.pt (count at build time) (DERIVED)</a:t>
+              <a:t>RAW_FOLDS_TRAINED = 4 &lt;- s26/models/p_ladder/raw_fold*_s0.pt (count at build time) (DERIVED)</a:t>
             </a:r>
           </a:p>
           <a:p>
@@ -6682,7 +6757,7 @@
                 </a:solidFill>
                 <a:latin typeface="Calibri"/>
               </a:rPr>
-              <a:t>10 / 11    from s26/PROPOSAL_C.md (lane P, 0a85323f with addendum 1) and s26/C3_RESULT.md addenda 1 to 4 (lane PH); verdicts L117 / L120; C2 basis: built chain, rebuild 3.2126 (L57)</a:t>
+              <a:t>10 / 11    from s26/PROPOSAL_C.md (lane P, with addenda 1 and 2) and s26/C3_RESULT.md addenda 1 to 4 (lane PH); verdicts L117 / L120; C5 L132; C2 basis: built chain, rebuild 3.2126 (L57)</a:t>
             </a:r>
           </a:p>
         </p:txBody>
@@ -6737,7 +6812,7 @@
                 </a:solidFill>
                 <a:latin typeface="Calibri"/>
               </a:rPr>
-              <a:t>• the prior bounds the accuracy; the premise is right and the four items are wrong as stated: learn a better PRIOR, not a ranker; AMBER for validity only; the routers are closed; C5 was running at the file's stamp (126 rows checkpointed at this build, complete = False: not a result) and keeps its pre-registration</a:t>
+              <a:t>• the prior bounds the accuracy; the premise is right and the four items are wrong as stated: learn a better PRIOR, not a ranker; AMBER for validity only; the routers are closed; C5 (predict and subtract the common mode) is closed at one agent-day: null (GLOBAL -0.009 / +0.031 A) to harmful (RIDGE +0.164 A, 1.79 x MDE, 5/5 folds), ORACLE ceilings -1.87 / -3.13 A</a:t>
             </a:r>
           </a:p>
           <a:p>
@@ -6817,7 +6892,7 @@
                 </a:solidFill>
                 <a:latin typeface="Calibri"/>
               </a:rPr>
-              <a:t>• every other variant (contact head only, per-fold PCA 32 / 128, 2.7x capacity, triangle update, pool-histogram mix) lands within +0.018 to +0.122 A of the shipped prior, under MDEs of 0.13 to 0.20 A; the mix rung chooses lam = 0 on 5/5 folds; raw: 3 of 5 folds trained, not evaluated</a:t>
+              <a:t>• every other variant (contact head only, per-fold PCA 32 / 128, 2.7x capacity, triangle update, pool-histogram mix) lands within +0.018 to +0.122 A of the shipped prior, under MDEs of 0.13 to 0.20 A; the mix rung chooses lam = 0 on 5/5 folds; raw: not run (4 of 5 folds trained, no evaluation)</a:t>
             </a:r>
           </a:p>
           <a:p>

</xml_diff>